<commit_message>
Remove legacy automatic edge detection and align code, report, and presentation with interactive 4-dot homography and pipeline memory
</commit_message>
<xml_diff>
--- a/Scanify_Presentation (1).pptx
+++ b/Scanify_Presentation (1).pptx
@@ -4307,8 +4307,7 @@
               </a:defRPr>
             </a:pPr>
             <a:r>
-              <a:rPr dirty="0"/>
-              <a:t>• Background Confusion: Difficulty detecting page boundaries when paper color matches the underlying surface.</a:t>
+              <a:t>• Low-Contrast Solved: Interactive 4-dot placement prevents background confusion that plagued automatic edge detection.</a:t>
             </a:r>
           </a:p>
           <a:p>
@@ -4339,8 +4338,7 @@
               </a:defRPr>
             </a:pPr>
             <a:r>
-              <a:rPr dirty="0"/>
-              <a:t>• Motion Blur: Severe blur destroys edge gradients, hindering Canny edge detection and text sharpening.</a:t>
+              <a:t>• Motion Blur: Severe camera shake degrades character stroke sharpness and thresholding quality.</a:t>
             </a:r>
           </a:p>
         </p:txBody>
@@ -4453,8 +4451,7 @@
               </a:defRPr>
             </a:pPr>
             <a:r>
-              <a:rPr dirty="0"/>
-              <a:t>• Advanced Corner Detection: Implement machine-learning-assisted boundary detection for complex backgrounds.</a:t>
+              <a:t>• Deep Learning Corner Suggestion: Add optional neural-assisted initial corner placement for high-speed batch scanning.</a:t>
             </a:r>
           </a:p>
           <a:p>
@@ -5047,7 +5044,7 @@
               </a:defRPr>
             </a:pPr>
             <a:r>
-              <a:t>• Automates page boundary detection to crop out distracting background surfaces instantly.</a:t>
+              <a:t>• Provides an interactive 4-corner crop canvas to isolate the document from any background.</a:t>
             </a:r>
           </a:p>
           <a:p>
@@ -5265,7 +5262,7 @@
               </a:defRPr>
             </a:pPr>
             <a:r>
-              <a:t>• Boundary Detection: Automatically locate the four outer corners of paper documents within complex backgrounds.</a:t>
+              <a:t>• Interactive Rectification: Place four draggable corner dots to map document boundaries regardless of background.</a:t>
             </a:r>
           </a:p>
           <a:p>
@@ -5436,7 +5433,7 @@
               </a:defRPr>
             </a:pPr>
             <a:r>
-              <a:t>• Lighting Dependency: Performance depends on adequate contrast between the document paper and its background surface.</a:t>
+              <a:t>• User-Guided Precision: Draggable corner markers bypass low-contrast table confusion completely.</a:t>
             </a:r>
           </a:p>
           <a:p>
@@ -5451,7 +5448,7 @@
               </a:defRPr>
             </a:pPr>
             <a:r>
-              <a:t>• Edge Visibility: Automatic boundary detection requires all four corners of the document to be clearly visible in the frame.</a:t>
+              <a:t>• Pipeline Memory: 'Keep' and 'Revert' allow chaining multiple processing steps sequentially.</a:t>
             </a:r>
           </a:p>
           <a:p>
@@ -5749,13 +5746,8 @@
             </a:r>
           </a:p>
           <a:p>
-            <a:br/>
-            <a:r>
-              <a:t>• Role in Scanify:</a:t>
-            </a:r>
-            <a:br/>
-            <a:r>
-              <a:t>Provides robust algorithms for image filtering, Canny edge detection, contour analysis, and geometric perspective transformations.</a:t>
+            <a:r>
+              <a:t>• Role in Scanify: Provides robust algorithms for noise filtering, 2D perspective homography rectification, histogram equalization, and adaptive thresholding.</a:t>
             </a:r>
           </a:p>
         </p:txBody>
@@ -6329,8 +6321,7 @@
               </a:defRPr>
             </a:pPr>
             <a:r>
-              <a:rPr dirty="0"/>
-              <a:t>3. Detect</a:t>
+              <a:t>3. Rectify</a:t>
             </a:r>
           </a:p>
           <a:p>
@@ -6345,8 +6336,7 @@
               </a:defRPr>
             </a:pPr>
             <a:r>
-              <a:rPr dirty="0"/>
-              <a:t>Canny edge detection and contours locate paper corners.</a:t>
+              <a:t>User drags 4 corner dots to define the document boundaries.</a:t>
             </a:r>
           </a:p>
         </p:txBody>
@@ -6849,16 +6839,7 @@
               </a:defRPr>
             </a:pPr>
             <a:r>
-              <a:rPr dirty="0"/>
-              <a:t>• User Control: Users can inspect intermediate outputs (such as detected boundaries or </a:t>
-            </a:r>
-            <a:r>
-              <a:rPr dirty="0" err="1"/>
-              <a:t>thresholded</a:t>
-            </a:r>
-            <a:r>
-              <a:rPr dirty="0"/>
-              <a:t> text) to verify accuracy before PDF compilation.</a:t>
+              <a:t>• Pipeline Memory: Users can 'Keep' intermediate results to chain multiple tools or 'Revert' back.</a:t>
             </a:r>
           </a:p>
         </p:txBody>
@@ -6919,7 +6900,7 @@
               </a:defRPr>
             </a:pPr>
             <a:r>
-              <a:t>Image Preparation &amp; Boundary Detection</a:t>
+              <a:t>Interactive 4-Corner Document Rectification</a:t>
             </a:r>
           </a:p>
           <a:p>
@@ -6935,7 +6916,7 @@
               </a:defRPr>
             </a:pPr>
             <a:r>
-              <a:t>Isolating the document region through grayscale conversion and contour analysis</a:t>
+              <a:t>Positioning document corners via HTML5 interactive canvas and homography mapping</a:t>
             </a:r>
           </a:p>
         </p:txBody>
@@ -7208,8 +7189,7 @@
               </a:defRPr>
             </a:pPr>
             <a:r>
-              <a:rPr dirty="0"/>
-              <a:t>3. Canny Edge Detection</a:t>
+              <a:t>3. Interactive 4-Dot Canvas</a:t>
             </a:r>
           </a:p>
           <a:p>
@@ -7224,8 +7204,7 @@
               </a:defRPr>
             </a:pPr>
             <a:r>
-              <a:rPr dirty="0"/>
-              <a:t>Identifies strong intensity gradients in the image, marking sharp boundaries where the paper meets the background table.</a:t>
+              <a:t>User drags 4 colored corner dots directly on the image, eliminating background contrast failure.</a:t>
             </a:r>
           </a:p>
         </p:txBody>
@@ -7306,7 +7285,7 @@
               </a:defRPr>
             </a:pPr>
             <a:r>
-              <a:t>4. Contour Analysis</a:t>
+              <a:t>4. Coordinate Topological Sorting</a:t>
             </a:r>
           </a:p>
           <a:p>
@@ -7321,7 +7300,7 @@
               </a:defRPr>
             </a:pPr>
             <a:r>
-              <a:t>Scans detected edges to find the largest closed four-sided polygon, successfully identifying the four outer corners of the document.</a:t>
+              <a:t>Topologically orders coordinates into TL, TR, BL, BR using Euclidean sum and difference projections.</a:t>
             </a:r>
           </a:p>
         </p:txBody>
@@ -7574,13 +7553,8 @@
             </a:r>
           </a:p>
           <a:p>
-            <a:br/>
-            <a:r>
-              <a:t>• Operational Detail:</a:t>
-            </a:r>
-            <a:br/>
-            <a:r>
-              <a:t>The four detected corner coordinates (top-left, top-right, bottom-right, bottom-left) are ordered precisely and mapped to destination dimensions.</a:t>
+            <a:r>
+              <a:t>• Operational Detail: The four user-positioned corner coordinates (TL, TR, BL, BR) are ordered topologically and mapped to destination dimensions.</a:t>
             </a:r>
           </a:p>
         </p:txBody>

</xml_diff>

<commit_message>
Update presentation slides with user modifications
</commit_message>
<xml_diff>
--- a/Scanify_Presentation (1).pptx
+++ b/Scanify_Presentation (1).pptx
@@ -134,6 +134,43 @@
 </p:presentation>
 </file>
 
+<file path=ppt/revisionInfo.xml><?xml version="1.0" encoding="utf-8"?>
+<p1510:revInfo xmlns:a="http://schemas.openxmlformats.org/drawingml/2006/main" xmlns:r="http://schemas.openxmlformats.org/officeDocument/2006/relationships" xmlns:p1510="http://schemas.microsoft.com/office/powerpoint/2015/10/main">
+  <p1510:revLst>
+    <p1510:client id="{7BDF5EA3-31F8-4B5C-BFCC-198313CDF4B6}" v="1" dt="2026-10-29T22:49:47.301"/>
+  </p1510:revLst>
+</p1510:revInfo>
+</file>
+
+<file path=ppt/changesInfos/changesInfo1.xml><?xml version="1.0" encoding="utf-8"?>
+<pc:chgInfo xmlns:a="http://schemas.openxmlformats.org/drawingml/2006/main" xmlns:r="http://schemas.openxmlformats.org/officeDocument/2006/relationships" xmlns:ac="http://schemas.microsoft.com/office/drawing/2013/main/command" xmlns:pc="http://schemas.microsoft.com/office/powerpoint/2013/main/command">
+  <pc:docChgLst>
+    <pc:chgData name="Sakshi Baghel" userId="7bcc07f3167598e0" providerId="LiveId" clId="{59B6434E-9FE3-4B5A-BCB8-28C516B1FEB3}"/>
+    <pc:docChg chg="modSld">
+      <pc:chgData name="Sakshi Baghel" userId="7bcc07f3167598e0" providerId="LiveId" clId="{59B6434E-9FE3-4B5A-BCB8-28C516B1FEB3}" dt="2026-10-29T22:49:52.905" v="163" actId="1076"/>
+      <pc:docMkLst>
+        <pc:docMk/>
+      </pc:docMkLst>
+      <pc:sldChg chg="modSp mod">
+        <pc:chgData name="Sakshi Baghel" userId="7bcc07f3167598e0" providerId="LiveId" clId="{59B6434E-9FE3-4B5A-BCB8-28C516B1FEB3}" dt="2026-10-29T22:49:52.905" v="163" actId="1076"/>
+        <pc:sldMkLst>
+          <pc:docMk/>
+          <pc:sldMk cId="0" sldId="256"/>
+        </pc:sldMkLst>
+        <pc:spChg chg="mod">
+          <ac:chgData name="Sakshi Baghel" userId="7bcc07f3167598e0" providerId="LiveId" clId="{59B6434E-9FE3-4B5A-BCB8-28C516B1FEB3}" dt="2026-10-29T22:49:52.905" v="163" actId="1076"/>
+          <ac:spMkLst>
+            <pc:docMk/>
+            <pc:sldMk cId="0" sldId="256"/>
+            <ac:spMk id="3" creationId="{00000000-0000-0000-0000-000000000000}"/>
+          </ac:spMkLst>
+        </pc:spChg>
+      </pc:sldChg>
+    </pc:docChg>
+  </pc:docChgLst>
+</pc:chgInfo>
+</file>
+
 <file path=ppt/slideLayouts/slideLayout1.xml><?xml version="1.0" encoding="utf-8"?>
 <p:sldLayout xmlns:a="http://schemas.openxmlformats.org/drawingml/2006/main" xmlns:r="http://schemas.openxmlformats.org/officeDocument/2006/relationships" xmlns:p="http://schemas.openxmlformats.org/presentationml/2006/main" type="title" preserve="1">
   <p:cSld name="Title Slide">
@@ -313,7 +350,7 @@
           <a:p>
             <a:fld id="{5BCAD085-E8A6-8845-BD4E-CB4CCA059FC4}" type="datetimeFigureOut">
               <a:rPr lang="en-US" smtClean="0"/>
-              <a:t>10/29/2026</a:t>
+              <a:t>10/30/2026</a:t>
             </a:fld>
             <a:endParaRPr lang="en-US"/>
           </a:p>
@@ -481,7 +518,7 @@
           <a:p>
             <a:fld id="{5BCAD085-E8A6-8845-BD4E-CB4CCA059FC4}" type="datetimeFigureOut">
               <a:rPr lang="en-US" smtClean="0"/>
-              <a:t>10/29/2026</a:t>
+              <a:t>10/30/2026</a:t>
             </a:fld>
             <a:endParaRPr lang="en-US"/>
           </a:p>
@@ -659,7 +696,7 @@
           <a:p>
             <a:fld id="{5BCAD085-E8A6-8845-BD4E-CB4CCA059FC4}" type="datetimeFigureOut">
               <a:rPr lang="en-US" smtClean="0"/>
-              <a:t>10/29/2026</a:t>
+              <a:t>10/30/2026</a:t>
             </a:fld>
             <a:endParaRPr lang="en-US"/>
           </a:p>
@@ -827,7 +864,7 @@
           <a:p>
             <a:fld id="{5BCAD085-E8A6-8845-BD4E-CB4CCA059FC4}" type="datetimeFigureOut">
               <a:rPr lang="en-US" smtClean="0"/>
-              <a:t>10/29/2026</a:t>
+              <a:t>10/30/2026</a:t>
             </a:fld>
             <a:endParaRPr lang="en-US"/>
           </a:p>
@@ -1072,7 +1109,7 @@
           <a:p>
             <a:fld id="{5BCAD085-E8A6-8845-BD4E-CB4CCA059FC4}" type="datetimeFigureOut">
               <a:rPr lang="en-US" smtClean="0"/>
-              <a:t>10/29/2026</a:t>
+              <a:t>10/30/2026</a:t>
             </a:fld>
             <a:endParaRPr lang="en-US"/>
           </a:p>
@@ -1357,7 +1394,7 @@
           <a:p>
             <a:fld id="{5BCAD085-E8A6-8845-BD4E-CB4CCA059FC4}" type="datetimeFigureOut">
               <a:rPr lang="en-US" smtClean="0"/>
-              <a:t>10/29/2026</a:t>
+              <a:t>10/30/2026</a:t>
             </a:fld>
             <a:endParaRPr lang="en-US"/>
           </a:p>
@@ -1776,7 +1813,7 @@
           <a:p>
             <a:fld id="{5BCAD085-E8A6-8845-BD4E-CB4CCA059FC4}" type="datetimeFigureOut">
               <a:rPr lang="en-US" smtClean="0"/>
-              <a:t>10/29/2026</a:t>
+              <a:t>10/30/2026</a:t>
             </a:fld>
             <a:endParaRPr lang="en-US"/>
           </a:p>
@@ -1893,7 +1930,7 @@
           <a:p>
             <a:fld id="{5BCAD085-E8A6-8845-BD4E-CB4CCA059FC4}" type="datetimeFigureOut">
               <a:rPr lang="en-US" smtClean="0"/>
-              <a:t>10/29/2026</a:t>
+              <a:t>10/30/2026</a:t>
             </a:fld>
             <a:endParaRPr lang="en-US"/>
           </a:p>
@@ -1988,7 +2025,7 @@
           <a:p>
             <a:fld id="{5BCAD085-E8A6-8845-BD4E-CB4CCA059FC4}" type="datetimeFigureOut">
               <a:rPr lang="en-US" smtClean="0"/>
-              <a:t>10/29/2026</a:t>
+              <a:t>10/30/2026</a:t>
             </a:fld>
             <a:endParaRPr lang="en-US"/>
           </a:p>
@@ -2263,7 +2300,7 @@
           <a:p>
             <a:fld id="{5BCAD085-E8A6-8845-BD4E-CB4CCA059FC4}" type="datetimeFigureOut">
               <a:rPr lang="en-US" smtClean="0"/>
-              <a:t>10/29/2026</a:t>
+              <a:t>10/30/2026</a:t>
             </a:fld>
             <a:endParaRPr lang="en-US"/>
           </a:p>
@@ -2515,7 +2552,7 @@
           <a:p>
             <a:fld id="{5BCAD085-E8A6-8845-BD4E-CB4CCA059FC4}" type="datetimeFigureOut">
               <a:rPr lang="en-US" smtClean="0"/>
-              <a:t>10/29/2026</a:t>
+              <a:t>10/30/2026</a:t>
             </a:fld>
             <a:endParaRPr lang="en-US"/>
           </a:p>
@@ -2726,7 +2763,7 @@
           <a:p>
             <a:fld id="{5BCAD085-E8A6-8845-BD4E-CB4CCA059FC4}" type="datetimeFigureOut">
               <a:rPr lang="en-US" smtClean="0"/>
-              <a:t>10/29/2026</a:t>
+              <a:t>10/30/2026</a:t>
             </a:fld>
             <a:endParaRPr lang="en-US"/>
           </a:p>
@@ -3155,8 +3192,8 @@
         </p:nvSpPr>
         <p:spPr>
           <a:xfrm>
-            <a:off x="1371600" y="1645920"/>
-            <a:ext cx="9448495" cy="4114800"/>
+            <a:off x="1371752" y="1213300"/>
+            <a:ext cx="9448495" cy="4129336"/>
           </a:xfrm>
           <a:prstGeom prst="rect">
             <a:avLst/>
@@ -3178,7 +3215,12 @@
               </a:defRPr>
             </a:pPr>
             <a:r>
-              <a:t>Scanify – Smart Document Scanner</a:t>
+              <a:rPr dirty="0" err="1"/>
+              <a:t>Scanify</a:t>
+            </a:r>
+            <a:r>
+              <a:rPr dirty="0"/>
+              <a:t> – Smart Document Scanner</a:t>
             </a:r>
           </a:p>
           <a:p>
@@ -3194,22 +3236,72 @@
               </a:defRPr>
             </a:pPr>
             <a:r>
+              <a:rPr dirty="0"/>
               <a:t>From Paper Photographs to Clear Digital Documents</a:t>
             </a:r>
           </a:p>
           <a:p>
-            <a:br/>
-            <a:r>
-              <a:t>A lightweight image-processing application built with Python, OpenCV, NumPy, and Streamlit that simplifies document digitization by cleaning, straightening, and converting smartphone photographs into professional digital PDFs.</a:t>
-            </a:r>
-          </a:p>
-          <a:p>
-            <a:br/>
-            <a:r>
-              <a:t>Presented by: Student Name | Roll Number: XXXXXX</a:t>
-            </a:r>
-            <a:br/>
-            <a:r>
+            <a:br>
+              <a:rPr dirty="0"/>
+            </a:br>
+            <a:r>
+              <a:rPr dirty="0"/>
+              <a:t>A lightweight image-processing application built with Python, OpenCV, NumPy, and </a:t>
+            </a:r>
+            <a:r>
+              <a:rPr dirty="0" err="1"/>
+              <a:t>Streamlit</a:t>
+            </a:r>
+            <a:r>
+              <a:rPr dirty="0"/>
+              <a:t> that simplifies document digitization by cleaning, straightening, and converting smartphone photographs into professional digital PDFs.</a:t>
+            </a:r>
+          </a:p>
+          <a:p>
+            <a:br>
+              <a:rPr dirty="0"/>
+            </a:br>
+            <a:r>
+              <a:rPr dirty="0"/>
+              <a:t>Presented by: S</a:t>
+            </a:r>
+            <a:r>
+              <a:rPr lang="en-US" dirty="0"/>
+              <a:t>akshi Baghel     </a:t>
+            </a:r>
+            <a:r>
+              <a:rPr dirty="0"/>
+              <a:t> | </a:t>
+            </a:r>
+            <a:r>
+              <a:rPr lang="en-US" dirty="0"/>
+              <a:t>20233244</a:t>
+            </a:r>
+          </a:p>
+          <a:p>
+            <a:r>
+              <a:rPr lang="en-US" dirty="0"/>
+              <a:t>			Neelam                | 20233366</a:t>
+            </a:r>
+          </a:p>
+          <a:p>
+            <a:r>
+              <a:rPr lang="en-US" dirty="0"/>
+              <a:t>			Manashvi Sewal | 20233177</a:t>
+            </a:r>
+          </a:p>
+          <a:p>
+            <a:r>
+              <a:rPr lang="en-US" dirty="0"/>
+              <a:t>			Ritu Raj                | 20233234</a:t>
+            </a:r>
+          </a:p>
+          <a:p>
+            <a:br>
+              <a:rPr dirty="0"/>
+            </a:br>
+            <a:r>
+              <a:rPr dirty="0"/>
               <a:t>Department of Computer Science &amp; Engineering | College Name</a:t>
             </a:r>
           </a:p>

</xml_diff>